<commit_message>
Trim merged Gmarket slide panel to four lines
Co-Authored-By: Claude Opus 5.5 <noreply@anthropic.com>
Claude-Session: https://claude.ai/code/session_01LNckV4PF1WFWnv5VJ442kU
</commit_message>
<xml_diff>
--- a/지마켓_브랜드검색어_통합_1장.pptx
+++ b/지마켓_브랜드검색어_통합_1장.pptx
@@ -4286,7 +4286,7 @@
                 <a:ea typeface="에이투지체 4 Regular"/>
                 <a:cs typeface="에이투지체 4 Regular"/>
               </a:rPr>
-              <a:t>키성장 FGO, 츄어블 철분, 프로바이오키드, 프로바이오틱스, 멀티비타민 등</a:t>
+              <a:t>키성장 FGO, 철분, 프로바이오키드, 멀티비타민 등</a:t>
             </a:r>
           </a:p>
           <a:p>
@@ -4315,7 +4315,7 @@
                 <a:ea typeface="에이투지체 4 Regular"/>
                 <a:cs typeface="에이투지체 4 Regular"/>
               </a:rPr>
-              <a:t>FGO 5박스, 4박스, 프로바이오키드 위주</a:t>
+              <a:t>FGO 5박스·4박스, 프로바이오키드 위주</a:t>
             </a:r>
           </a:p>
           <a:p>
@@ -4344,36 +4344,7 @@
                 <a:ea typeface="에이투지체 4 Regular"/>
                 <a:cs typeface="에이투지체 4 Regular"/>
               </a:rPr>
-              <a:t>나머지 광고에 뉴트리원, 녹십초 노출</a:t>
-            </a:r>
-          </a:p>
-          <a:p>
-            <a:pPr algn="l">
-              <a:spcAft>
-                <a:spcPts val="800"/>
-              </a:spcAft>
-            </a:pPr>
-            <a:r>
-              <a:rPr sz="1100" b="0">
-                <a:solidFill>
-                  <a:srgbClr val="004F9F"/>
-                </a:solidFill>
-                <a:latin typeface="에이투지체 6 SemiBold"/>
-                <a:ea typeface="에이투지체 6 SemiBold"/>
-                <a:cs typeface="에이투지체 6 SemiBold"/>
-              </a:rPr>
-              <a:t>확인  </a:t>
-            </a:r>
-            <a:r>
-              <a:rPr sz="1100" b="0">
-                <a:solidFill>
-                  <a:srgbClr val="222222"/>
-                </a:solidFill>
-                <a:latin typeface="에이투지체 4 Regular"/>
-                <a:ea typeface="에이투지체 4 Regular"/>
-                <a:cs typeface="에이투지체 4 Regular"/>
-              </a:rPr>
-              <a:t>첫 번째 광고가 1박스가 아닌 5박스(76.9만 원) 구성</a:t>
+              <a:t>남은 광고는 뉴트리원, 녹십초</a:t>
             </a:r>
           </a:p>
           <a:p>
@@ -4402,65 +4373,7 @@
                 <a:ea typeface="에이투지체 4 Regular"/>
                 <a:cs typeface="에이투지체 4 Regular"/>
               </a:rPr>
-              <a:t>키움정 검색 결과는 광고 5개 모두 키움정</a:t>
-            </a:r>
-          </a:p>
-          <a:p>
-            <a:pPr algn="l">
-              <a:spcAft>
-                <a:spcPts val="800"/>
-              </a:spcAft>
-            </a:pPr>
-            <a:r>
-              <a:rPr sz="1100" b="0">
-                <a:solidFill>
-                  <a:srgbClr val="004F9F"/>
-                </a:solidFill>
-                <a:latin typeface="에이투지체 6 SemiBold"/>
-                <a:ea typeface="에이투지체 6 SemiBold"/>
-                <a:cs typeface="에이투지체 6 SemiBold"/>
-              </a:rPr>
-              <a:t>운영  </a:t>
-            </a:r>
-            <a:r>
-              <a:rPr sz="1100" b="0">
-                <a:solidFill>
-                  <a:srgbClr val="222222"/>
-                </a:solidFill>
-                <a:latin typeface="에이투지체 4 Regular"/>
-                <a:ea typeface="에이투지체 4 Regular"/>
-                <a:cs typeface="에이투지체 4 Regular"/>
-              </a:rPr>
-              <a:t>브랜드 검색어 그룹에 판매 상품 모두 등록</a:t>
-            </a:r>
-          </a:p>
-          <a:p>
-            <a:pPr algn="l">
-              <a:spcAft>
-                <a:spcPts val="800"/>
-              </a:spcAft>
-            </a:pPr>
-            <a:r>
-              <a:rPr sz="1100" b="0">
-                <a:solidFill>
-                  <a:srgbClr val="004F9F"/>
-                </a:solidFill>
-                <a:latin typeface="에이투지체 6 SemiBold"/>
-                <a:ea typeface="에이투지체 6 SemiBold"/>
-                <a:cs typeface="에이투지체 6 SemiBold"/>
-              </a:rPr>
-              <a:t>입찰  </a:t>
-            </a:r>
-            <a:r>
-              <a:rPr sz="1100" b="0">
-                <a:solidFill>
-                  <a:srgbClr val="222222"/>
-                </a:solidFill>
-                <a:latin typeface="에이투지체 4 Regular"/>
-                <a:ea typeface="에이투지체 4 Regular"/>
-                <a:cs typeface="에이투지체 4 Regular"/>
-              </a:rPr>
-              <a:t>경쟁이 적은 브랜드 검색어는 입찰가를 낮게 설정해 ROAS 상승</a:t>
+              <a:t>키움정 검색 광고는 5개 모두 키움정</a:t>
             </a:r>
           </a:p>
         </p:txBody>

</xml_diff>

<commit_message>
Rework merged Gmarket slide: two captures side by side with short captions
Co-Authored-By: Claude Opus 5.5 <noreply@anthropic.com>
Claude-Session: https://claude.ai/code/session_01LNckV4PF1WFWnv5VJ442kU
</commit_message>
<xml_diff>
--- a/지마켓_브랜드검색어_통합_1장.pptx
+++ b/지마켓_브랜드검색어_통합_1장.pptx
@@ -4087,7 +4087,7 @@
         <p:spPr>
           <a:xfrm>
             <a:off x="548640" y="1993392"/>
-            <a:ext cx="6400800" cy="292608"/>
+            <a:ext cx="4841607" cy="292608"/>
           </a:xfrm>
           <a:prstGeom prst="rect">
             <a:avLst/>
@@ -4143,7 +4143,7 @@
         <p:spPr>
           <a:xfrm>
             <a:off x="548640" y="2331720"/>
-            <a:ext cx="6400800" cy="2901297"/>
+            <a:ext cx="4841607" cy="2194560"/>
           </a:xfrm>
           <a:prstGeom prst="rect">
             <a:avLst/>
@@ -4157,61 +4157,14 @@
       </p:pic>
       <p:sp>
         <p:nvSpPr>
-          <p:cNvPr id="13" name="Rounded Rectangle 12"/>
-          <p:cNvSpPr/>
+          <p:cNvPr id="15" name="TextBox 14"/>
+          <p:cNvSpPr txBox="1"/>
           <p:nvPr/>
         </p:nvSpPr>
         <p:spPr>
           <a:xfrm>
-            <a:off x="7223760" y="2331720"/>
-            <a:ext cx="4389120" cy="2971800"/>
-          </a:xfrm>
-          <a:prstGeom prst="roundRect">
-            <a:avLst>
-              <a:gd name="adj" fmla="val 2461"/>
-            </a:avLst>
-          </a:prstGeom>
-          <a:solidFill>
-            <a:srgbClr val="F5F5F5"/>
-          </a:solidFill>
-          <a:ln>
-            <a:noFill/>
-          </a:ln>
-          <a:effectLst/>
-        </p:spPr>
-        <p:style>
-          <a:lnRef idx="1">
-            <a:schemeClr val="accent1"/>
-          </a:lnRef>
-          <a:fillRef idx="3">
-            <a:schemeClr val="accent1"/>
-          </a:fillRef>
-          <a:effectRef idx="2">
-            <a:schemeClr val="accent1"/>
-          </a:effectRef>
-          <a:fontRef idx="minor">
-            <a:schemeClr val="lt1"/>
-          </a:fontRef>
-        </p:style>
-        <p:txBody>
-          <a:bodyPr rtlCol="0" anchor="ctr"/>
-          <a:lstStyle/>
-          <a:p>
-            <a:pPr algn="ctr"/>
-            <a:endParaRPr/>
-          </a:p>
-        </p:txBody>
-      </p:sp>
-      <p:sp>
-        <p:nvSpPr>
-          <p:cNvPr id="14" name="TextBox 13"/>
-          <p:cNvSpPr txBox="1"/>
-          <p:nvPr/>
-        </p:nvSpPr>
-        <p:spPr>
-          <a:xfrm>
-            <a:off x="7452360" y="2450592"/>
-            <a:ext cx="3931920" cy="320040"/>
+            <a:off x="548640" y="4663440"/>
+            <a:ext cx="4841607" cy="640080"/>
           </a:xfrm>
           <a:prstGeom prst="rect">
             <a:avLst/>
@@ -4223,72 +4176,6 @@
             <a:spAutoFit/>
           </a:bodyPr>
           <a:lstStyle/>
-          <a:p>
-            <a:pPr algn="l"/>
-            <a:r>
-              <a:rPr sz="1350" b="0">
-                <a:solidFill>
-                  <a:srgbClr val="222222"/>
-                </a:solidFill>
-                <a:latin typeface="에이투지체 8 ExtraBold"/>
-                <a:ea typeface="에이투지체 8 ExtraBold"/>
-                <a:cs typeface="에이투지체 8 ExtraBold"/>
-              </a:rPr>
-              <a:t>판매 중  vs  광고 영역 노출</a:t>
-            </a:r>
-          </a:p>
-        </p:txBody>
-      </p:sp>
-      <p:sp>
-        <p:nvSpPr>
-          <p:cNvPr id="15" name="TextBox 14"/>
-          <p:cNvSpPr txBox="1"/>
-          <p:nvPr/>
-        </p:nvSpPr>
-        <p:spPr>
-          <a:xfrm>
-            <a:off x="7452360" y="2880360"/>
-            <a:ext cx="3977639" cy="2377440"/>
-          </a:xfrm>
-          <a:prstGeom prst="rect">
-            <a:avLst/>
-          </a:prstGeom>
-          <a:noFill/>
-        </p:spPr>
-        <p:txBody>
-          <a:bodyPr wrap="square" lIns="0" tIns="0" rIns="0" bIns="0" anchor="t">
-            <a:spAutoFit/>
-          </a:bodyPr>
-          <a:lstStyle/>
-          <a:p>
-            <a:pPr algn="l">
-              <a:spcAft>
-                <a:spcPts val="800"/>
-              </a:spcAft>
-            </a:pPr>
-            <a:r>
-              <a:rPr sz="1100" b="0">
-                <a:solidFill>
-                  <a:srgbClr val="004F9F"/>
-                </a:solidFill>
-                <a:latin typeface="에이투지체 6 SemiBold"/>
-                <a:ea typeface="에이투지체 6 SemiBold"/>
-                <a:cs typeface="에이투지체 6 SemiBold"/>
-              </a:rPr>
-              <a:t>판매 중  </a:t>
-            </a:r>
-            <a:r>
-              <a:rPr sz="1100" b="0">
-                <a:solidFill>
-                  <a:srgbClr val="222222"/>
-                </a:solidFill>
-                <a:latin typeface="에이투지체 4 Regular"/>
-                <a:ea typeface="에이투지체 4 Regular"/>
-                <a:cs typeface="에이투지체 4 Regular"/>
-              </a:rPr>
-              <a:t>키성장 FGO, 철분, 프로바이오키드, 멀티비타민 등</a:t>
-            </a:r>
-          </a:p>
           <a:p>
             <a:pPr algn="l">
               <a:spcAft>
@@ -4347,14 +4234,114 @@
               <a:t>남은 광고는 뉴트리원, 녹십초</a:t>
             </a:r>
           </a:p>
+        </p:txBody>
+      </p:sp>
+      <p:sp>
+        <p:nvSpPr>
+          <p:cNvPr id="16" name="TextBox 13"/>
+          <p:cNvSpPr txBox="1"/>
+          <p:nvPr/>
+        </p:nvSpPr>
+        <p:spPr>
+          <a:xfrm>
+            <a:off x="5943600" y="1993392"/>
+            <a:ext cx="5669280" cy="292608"/>
+          </a:xfrm>
+          <a:prstGeom prst="rect">
+            <a:avLst/>
+          </a:prstGeom>
+          <a:noFill/>
+        </p:spPr>
+        <p:txBody>
+          <a:bodyPr wrap="square" lIns="0" tIns="0" rIns="0" bIns="0" anchor="t">
+            <a:spAutoFit/>
+          </a:bodyPr>
+          <a:lstStyle/>
+          <a:p>
+            <a:pPr algn="l"/>
+            <a:r>
+              <a:rPr sz="1250" b="0">
+                <a:solidFill>
+                  <a:srgbClr val="004F9F"/>
+                </a:solidFill>
+                <a:latin typeface="에이투지체 8 ExtraBold"/>
+                <a:ea typeface="에이투지체 8 ExtraBold"/>
+                <a:cs typeface="에이투지체 8 ExtraBold"/>
+              </a:rPr>
+              <a:t>"키움정"  </a:t>
+            </a:r>
+            <a:r>
+              <a:rPr sz="1250" b="0">
+                <a:solidFill>
+                  <a:srgbClr val="222222"/>
+                </a:solidFill>
+                <a:latin typeface="에이투지체 6 SemiBold"/>
+                <a:ea typeface="에이투지체 6 SemiBold"/>
+                <a:cs typeface="에이투지체 6 SemiBold"/>
+              </a:rPr>
+              <a:t>경쟁사 브랜드 검색어</a:t>
+            </a:r>
+          </a:p>
+        </p:txBody>
+      </p:sp>
+      <p:pic>
+        <p:nvPicPr>
+          <p:cNvPr id="17" name="Picture 14" descr="g_kium.png"/>
+          <p:cNvPicPr>
+            <a:picLocks noChangeAspect="1"/>
+          </p:cNvPicPr>
+          <p:nvPr/>
+        </p:nvPicPr>
+        <p:blipFill>
+          <a:blip r:embed="rId9"/>
+          <a:stretch>
+            <a:fillRect/>
+          </a:stretch>
+        </p:blipFill>
+        <p:spPr>
+          <a:xfrm>
+            <a:off x="5943600" y="2331720"/>
+            <a:ext cx="2895458" cy="2194560"/>
+          </a:xfrm>
+          <a:prstGeom prst="rect">
+            <a:avLst/>
+          </a:prstGeom>
+          <a:ln w="9525">
+            <a:solidFill>
+              <a:srgbClr val="DDDDDD"/>
+            </a:solidFill>
+          </a:ln>
+        </p:spPr>
+      </p:pic>
+      <p:sp>
+        <p:nvSpPr>
+          <p:cNvPr id="18" name="TextBox 15"/>
+          <p:cNvSpPr txBox="1"/>
+          <p:nvPr/>
+        </p:nvSpPr>
+        <p:spPr>
+          <a:xfrm>
+            <a:off x="5943600" y="4663440"/>
+            <a:ext cx="5669280" cy="640080"/>
+          </a:xfrm>
+          <a:prstGeom prst="rect">
+            <a:avLst/>
+          </a:prstGeom>
+          <a:noFill/>
+        </p:spPr>
+        <p:txBody>
+          <a:bodyPr wrap="square" lIns="0" tIns="0" rIns="0" bIns="0" anchor="t">
+            <a:spAutoFit/>
+          </a:bodyPr>
+          <a:lstStyle/>
           <a:p>
             <a:pPr algn="l">
               <a:spcAft>
-                <a:spcPts val="800"/>
+                <a:spcPts val="700"/>
               </a:spcAft>
             </a:pPr>
             <a:r>
-              <a:rPr sz="1100" b="0">
+              <a:rPr sz="1050" b="0">
                 <a:solidFill>
                   <a:srgbClr val="004F9F"/>
                 </a:solidFill>
@@ -4362,10 +4349,10 @@
                 <a:ea typeface="에이투지체 6 SemiBold"/>
                 <a:cs typeface="에이투지체 6 SemiBold"/>
               </a:rPr>
-              <a:t>비교  </a:t>
-            </a:r>
-            <a:r>
-              <a:rPr sz="1100" b="0">
+              <a:t>광고  </a:t>
+            </a:r>
+            <a:r>
+              <a:rPr sz="1050" b="0">
                 <a:solidFill>
                   <a:srgbClr val="222222"/>
                 </a:solidFill>
@@ -4373,7 +4360,36 @@
                 <a:ea typeface="에이투지체 4 Regular"/>
                 <a:cs typeface="에이투지체 4 Regular"/>
               </a:rPr>
-              <a:t>키움정 검색 광고는 5개 모두 키움정</a:t>
+              <a:t>5개 모두 키움정 상품</a:t>
+            </a:r>
+          </a:p>
+          <a:p>
+            <a:pPr algn="l">
+              <a:spcAft>
+                <a:spcPts val="700"/>
+              </a:spcAft>
+            </a:pPr>
+            <a:r>
+              <a:rPr sz="1050" b="0">
+                <a:solidFill>
+                  <a:srgbClr val="004F9F"/>
+                </a:solidFill>
+                <a:latin typeface="에이투지체 6 SemiBold"/>
+                <a:ea typeface="에이투지체 6 SemiBold"/>
+                <a:cs typeface="에이투지체 6 SemiBold"/>
+              </a:rPr>
+              <a:t>두드림  </a:t>
+            </a:r>
+            <a:r>
+              <a:rPr sz="1050" b="0">
+                <a:solidFill>
+                  <a:srgbClr val="222222"/>
+                </a:solidFill>
+                <a:latin typeface="에이투지체 4 Regular"/>
+                <a:ea typeface="에이투지체 4 Regular"/>
+                <a:cs typeface="에이투지체 4 Regular"/>
+              </a:rPr>
+              <a:t>노출 없음</a:t>
             </a:r>
           </a:p>
         </p:txBody>

</xml_diff>

<commit_message>
Use new top-3 competitor capture, enlarged with side captions
Co-Authored-By: Claude Opus 5.5 <noreply@anthropic.com>
Claude-Session: https://claude.ai/code/session_01LNckV4PF1WFWnv5VJ442kU
</commit_message>
<xml_diff>
--- a/지마켓_브랜드검색어_통합_1장.pptx
+++ b/지마켓_브랜드검색어_통합_1장.pptx
@@ -4294,7 +4294,7 @@
         </p:nvPicPr>
         <p:blipFill>
           <a:blip r:embed="rId9"/>
-          <a:srcRect b="24806"/>
+          <a:srcRect r="5832"/>
           <a:stretch>
             <a:fillRect/>
           </a:stretch>
@@ -4302,7 +4302,7 @@
         <p:spPr>
           <a:xfrm>
             <a:off x="5943600" y="2331720"/>
-            <a:ext cx="3850661" cy="2194560"/>
+            <a:ext cx="3968468" cy="2971800"/>
           </a:xfrm>
           <a:prstGeom prst="rect">
             <a:avLst/>
@@ -4322,8 +4322,8 @@
         </p:nvSpPr>
         <p:spPr>
           <a:xfrm>
-            <a:off x="5943600" y="4663440"/>
-            <a:ext cx="5669280" cy="640080"/>
+            <a:off x="10049228" y="2331720"/>
+            <a:ext cx="1563652" cy="1280160"/>
           </a:xfrm>
           <a:prstGeom prst="rect">
             <a:avLst/>
@@ -4361,7 +4361,7 @@
                 <a:ea typeface="에이투지체 4 Regular"/>
                 <a:cs typeface="에이투지체 4 Regular"/>
               </a:rPr>
-              <a:t>5개 모두 키움정 상품</a:t>
+              <a:t>전부 키움정</a:t>
             </a:r>
           </a:p>
           <a:p>

</xml_diff>